<commit_message>
Extra credit: remove BIO.md and bus313-portfolio references
The bio lives in README.md (200-400 words), not a separate BIO.md --
already true in the assignment md after the last merge. Removed the
remaining BIO.md mentions (legacy-submission note, grading row, slide
labels/instructions) and the bus313-portfolio repo-name suggestion
(the portfolio repo is named for the student: firstname-lastname) from
both extra-credit-github-portfolio.md and the accompanying pptx.

pptx edits were run-level text replacements via python-pptx, formatting
untouched; no slide removed (slide 5 covers writing the bio generally,
not just the BIO.md filename). Verified with a PowerPoint COM open test
on a scratchpad copy: opens clean, 8 slides, no repair prompt.

Co-Authored-By: Claude Opus 5.5 <noreply@anthropic.com>
</commit_message>
<xml_diff>
--- a/courses/International-Economics-And-Trade/projects/github-portfolio-extra-credit/BUS313_Extra_Credit_GitHub_Portfolio.pptx
+++ b/courses/International-Economics-And-Trade/projects/github-portfolio-extra-credit/BUS313_Extra_Credit_GitHub_Portfolio.pptx
@@ -1517,6 +1517,10 @@
           </a:solidFill>
           <a:ln/>
         </p:spPr>
+        <p:txBody>
+          <a:bodyPr/>
+          <a:p/>
+        </p:txBody>
       </p:sp>
       <p:sp>
         <p:nvSpPr>
@@ -1537,6 +1541,10 @@
           </a:solidFill>
           <a:ln/>
         </p:spPr>
+        <p:txBody>
+          <a:bodyPr/>
+          <a:p/>
+        </p:txBody>
       </p:sp>
       <p:sp>
         <p:nvSpPr>
@@ -1681,6 +1689,10 @@
             <a:prstDash val="solid"/>
           </a:ln>
         </p:spPr>
+        <p:txBody>
+          <a:bodyPr/>
+          <a:p/>
+        </p:txBody>
       </p:sp>
       <p:sp>
         <p:nvSpPr>
@@ -1786,6 +1798,10 @@
             <a:prstDash val="solid"/>
           </a:ln>
         </p:spPr>
+        <p:txBody>
+          <a:bodyPr/>
+          <a:p/>
+        </p:txBody>
       </p:sp>
       <p:sp>
         <p:nvSpPr>
@@ -1859,7 +1875,7 @@
                 <a:ea typeface="Open Sans" pitchFamily="34" charset="-122"/>
                 <a:cs typeface="Open Sans" pitchFamily="34" charset="-120"/>
               </a:rPr>
-              <a:t>BIO.md</a:t>
+              <a:t>README bio</a:t>
             </a:r>
             <a:endParaRPr lang="en-US" sz="1700" dirty="0"/>
           </a:p>
@@ -1891,6 +1907,10 @@
             <a:prstDash val="solid"/>
           </a:ln>
         </p:spPr>
+        <p:txBody>
+          <a:bodyPr/>
+          <a:p/>
+        </p:txBody>
       </p:sp>
       <p:sp>
         <p:nvSpPr>
@@ -2099,6 +2119,10 @@
           </a:solidFill>
           <a:ln/>
         </p:spPr>
+        <p:txBody>
+          <a:bodyPr/>
+          <a:p/>
+        </p:txBody>
       </p:sp>
       <p:sp>
         <p:nvSpPr>
@@ -2243,6 +2267,10 @@
             </a:outerShdw>
           </a:effectLst>
         </p:spPr>
+        <p:txBody>
+          <a:bodyPr/>
+          <a:p/>
+        </p:txBody>
       </p:sp>
       <p:sp>
         <p:nvSpPr>
@@ -2263,6 +2291,10 @@
           </a:solidFill>
           <a:ln/>
         </p:spPr>
+        <p:txBody>
+          <a:bodyPr/>
+          <a:p/>
+        </p:txBody>
       </p:sp>
       <p:sp>
         <p:nvSpPr>
@@ -2283,6 +2315,10 @@
           </a:solidFill>
           <a:ln/>
         </p:spPr>
+        <p:txBody>
+          <a:bodyPr/>
+          <a:p/>
+        </p:txBody>
       </p:sp>
       <p:sp>
         <p:nvSpPr>
@@ -2427,6 +2463,10 @@
             </a:outerShdw>
           </a:effectLst>
         </p:spPr>
+        <p:txBody>
+          <a:bodyPr/>
+          <a:p/>
+        </p:txBody>
       </p:sp>
       <p:sp>
         <p:nvSpPr>
@@ -2447,6 +2487,10 @@
           </a:solidFill>
           <a:ln/>
         </p:spPr>
+        <p:txBody>
+          <a:bodyPr/>
+          <a:p/>
+        </p:txBody>
       </p:sp>
       <p:sp>
         <p:nvSpPr>
@@ -2467,6 +2511,10 @@
           </a:solidFill>
           <a:ln/>
         </p:spPr>
+        <p:txBody>
+          <a:bodyPr/>
+          <a:p/>
+        </p:txBody>
       </p:sp>
       <p:sp>
         <p:nvSpPr>
@@ -2611,6 +2659,10 @@
             </a:outerShdw>
           </a:effectLst>
         </p:spPr>
+        <p:txBody>
+          <a:bodyPr/>
+          <a:p/>
+        </p:txBody>
       </p:sp>
       <p:sp>
         <p:nvSpPr>
@@ -2631,6 +2683,10 @@
           </a:solidFill>
           <a:ln/>
         </p:spPr>
+        <p:txBody>
+          <a:bodyPr/>
+          <a:p/>
+        </p:txBody>
       </p:sp>
       <p:sp>
         <p:nvSpPr>
@@ -2651,6 +2707,10 @@
           </a:solidFill>
           <a:ln/>
         </p:spPr>
+        <p:txBody>
+          <a:bodyPr/>
+          <a:p/>
+        </p:txBody>
       </p:sp>
       <p:sp>
         <p:nvSpPr>
@@ -2830,6 +2890,10 @@
             <a:prstDash val="solid"/>
           </a:ln>
         </p:spPr>
+        <p:txBody>
+          <a:bodyPr/>
+          <a:p/>
+        </p:txBody>
       </p:sp>
       <p:sp>
         <p:nvSpPr>
@@ -2960,6 +3024,10 @@
           </a:solidFill>
           <a:ln/>
         </p:spPr>
+        <p:txBody>
+          <a:bodyPr/>
+          <a:p/>
+        </p:txBody>
       </p:sp>
       <p:sp>
         <p:nvSpPr>
@@ -3109,6 +3177,10 @@
             </a:outerShdw>
           </a:effectLst>
         </p:spPr>
+        <p:txBody>
+          <a:bodyPr/>
+          <a:p/>
+        </p:txBody>
       </p:sp>
       <p:sp>
         <p:nvSpPr>
@@ -3129,6 +3201,10 @@
           </a:solidFill>
           <a:ln/>
         </p:spPr>
+        <p:txBody>
+          <a:bodyPr/>
+          <a:p/>
+        </p:txBody>
       </p:sp>
       <p:sp>
         <p:nvSpPr>
@@ -3278,6 +3354,10 @@
             </a:outerShdw>
           </a:effectLst>
         </p:spPr>
+        <p:txBody>
+          <a:bodyPr/>
+          <a:p/>
+        </p:txBody>
       </p:sp>
       <p:sp>
         <p:nvSpPr>
@@ -3298,6 +3378,10 @@
           </a:solidFill>
           <a:ln/>
         </p:spPr>
+        <p:txBody>
+          <a:bodyPr/>
+          <a:p/>
+        </p:txBody>
       </p:sp>
       <p:sp>
         <p:nvSpPr>
@@ -3371,7 +3455,7 @@
                 <a:ea typeface="Open Sans" pitchFamily="34" charset="-122"/>
                 <a:cs typeface="Open Sans" pitchFamily="34" charset="-120"/>
               </a:rPr>
-              <a:t>BIO.md</a:t>
+              <a:t>README bio</a:t>
             </a:r>
             <a:endParaRPr lang="en-US" sz="2300" dirty="0"/>
           </a:p>
@@ -3447,6 +3531,10 @@
             </a:outerShdw>
           </a:effectLst>
         </p:spPr>
+        <p:txBody>
+          <a:bodyPr/>
+          <a:p/>
+        </p:txBody>
       </p:sp>
       <p:sp>
         <p:nvSpPr>
@@ -3467,6 +3555,10 @@
           </a:solidFill>
           <a:ln/>
         </p:spPr>
+        <p:txBody>
+          <a:bodyPr/>
+          <a:p/>
+        </p:txBody>
       </p:sp>
       <p:sp>
         <p:nvSpPr>
@@ -3604,6 +3696,10 @@
           </a:solidFill>
           <a:ln/>
         </p:spPr>
+        <p:txBody>
+          <a:bodyPr/>
+          <a:p/>
+        </p:txBody>
       </p:sp>
       <p:sp>
         <p:nvSpPr>
@@ -3680,6 +3776,10 @@
             <a:prstDash val="solid"/>
           </a:ln>
         </p:spPr>
+        <p:txBody>
+          <a:bodyPr/>
+          <a:p/>
+        </p:txBody>
       </p:sp>
       <p:sp>
         <p:nvSpPr>
@@ -3810,6 +3910,10 @@
           </a:solidFill>
           <a:ln/>
         </p:spPr>
+        <p:txBody>
+          <a:bodyPr/>
+          <a:p/>
+        </p:txBody>
       </p:sp>
       <p:sp>
         <p:nvSpPr>
@@ -3908,6 +4012,10 @@
           </a:solidFill>
           <a:ln/>
         </p:spPr>
+        <p:txBody>
+          <a:bodyPr/>
+          <a:p/>
+        </p:txBody>
       </p:sp>
       <p:sp>
         <p:nvSpPr>
@@ -4006,6 +4114,10 @@
           </a:solidFill>
           <a:ln/>
         </p:spPr>
+        <p:txBody>
+          <a:bodyPr/>
+          <a:p/>
+        </p:txBody>
       </p:sp>
       <p:sp>
         <p:nvSpPr>
@@ -4104,6 +4216,10 @@
           </a:solidFill>
           <a:ln/>
         </p:spPr>
+        <p:txBody>
+          <a:bodyPr/>
+          <a:p/>
+        </p:txBody>
       </p:sp>
       <p:sp>
         <p:nvSpPr>
@@ -4202,6 +4318,10 @@
           </a:solidFill>
           <a:ln/>
         </p:spPr>
+        <p:txBody>
+          <a:bodyPr/>
+          <a:p/>
+        </p:txBody>
       </p:sp>
       <p:sp>
         <p:nvSpPr>
@@ -4275,7 +4395,7 @@
                 <a:ea typeface="Open Sans" pitchFamily="34" charset="-122"/>
                 <a:cs typeface="Open Sans" pitchFamily="34" charset="-120"/>
               </a:rPr>
-              <a:t>Name it bus313-portfolio (hyphens are conventional).</a:t>
+              <a:t>Name it firstname-lastname (hyphens are conventional).</a:t>
             </a:r>
             <a:endParaRPr lang="en-US" sz="1350" dirty="0"/>
           </a:p>
@@ -4300,6 +4420,10 @@
           </a:solidFill>
           <a:ln/>
         </p:spPr>
+        <p:txBody>
+          <a:bodyPr/>
+          <a:p/>
+        </p:txBody>
       </p:sp>
       <p:sp>
         <p:nvSpPr>
@@ -4398,6 +4522,10 @@
           </a:solidFill>
           <a:ln/>
         </p:spPr>
+        <p:txBody>
+          <a:bodyPr/>
+          <a:p/>
+        </p:txBody>
       </p:sp>
       <p:sp>
         <p:nvSpPr>
@@ -4503,6 +4631,10 @@
             </a:outerShdw>
           </a:effectLst>
         </p:spPr>
+        <p:txBody>
+          <a:bodyPr/>
+          <a:p/>
+        </p:txBody>
       </p:sp>
       <p:sp>
         <p:nvSpPr>
@@ -4799,6 +4931,10 @@
             <a:prstDash val="solid"/>
           </a:ln>
         </p:spPr>
+        <p:txBody>
+          <a:bodyPr/>
+          <a:p/>
+        </p:txBody>
       </p:sp>
       <p:sp>
         <p:nvSpPr>
@@ -4929,6 +5065,10 @@
           </a:solidFill>
           <a:ln/>
         </p:spPr>
+        <p:txBody>
+          <a:bodyPr/>
+          <a:p/>
+        </p:txBody>
       </p:sp>
       <p:sp>
         <p:nvSpPr>
@@ -5002,7 +5142,7 @@
                 <a:ea typeface="Open Sans" pitchFamily="34" charset="-122"/>
                 <a:cs typeface="Open Sans" pitchFamily="34" charset="-120"/>
               </a:rPr>
-              <a:t>Add your bio  ·  BIO.md</a:t>
+              <a:t>Add your bio  ·  README.md</a:t>
             </a:r>
             <a:endParaRPr lang="en-US" sz="3000" dirty="0"/>
           </a:p>
@@ -5073,6 +5213,10 @@
             </a:outerShdw>
           </a:effectLst>
         </p:spPr>
+        <p:txBody>
+          <a:bodyPr/>
+          <a:p/>
+        </p:txBody>
       </p:sp>
       <p:sp>
         <p:nvSpPr>
@@ -5093,6 +5237,10 @@
           </a:solidFill>
           <a:ln/>
         </p:spPr>
+        <p:txBody>
+          <a:bodyPr/>
+          <a:p/>
+        </p:txBody>
       </p:sp>
       <p:sp>
         <p:nvSpPr>
@@ -5196,6 +5344,10 @@
             <a:prstDash val="solid"/>
           </a:ln>
         </p:spPr>
+        <p:txBody>
+          <a:bodyPr/>
+          <a:p/>
+        </p:txBody>
       </p:sp>
       <p:sp>
         <p:nvSpPr>
@@ -5306,6 +5458,10 @@
             </a:outerShdw>
           </a:effectLst>
         </p:spPr>
+        <p:txBody>
+          <a:bodyPr/>
+          <a:p/>
+        </p:txBody>
       </p:sp>
       <p:sp>
         <p:nvSpPr>
@@ -5326,6 +5482,10 @@
           </a:solidFill>
           <a:ln/>
         </p:spPr>
+        <p:txBody>
+          <a:bodyPr/>
+          <a:p/>
+        </p:txBody>
       </p:sp>
       <p:sp>
         <p:nvSpPr>
@@ -5385,6 +5545,10 @@
           </a:solidFill>
           <a:ln/>
         </p:spPr>
+        <p:txBody>
+          <a:bodyPr/>
+          <a:p/>
+        </p:txBody>
       </p:sp>
       <p:sp>
         <p:nvSpPr>
@@ -5458,7 +5622,7 @@
                 <a:ea typeface="Open Sans" pitchFamily="34" charset="-122"/>
                 <a:cs typeface="Open Sans" pitchFamily="34" charset="-120"/>
               </a:rPr>
-              <a:t>In your repo, click Add file → Create new file.</a:t>
+              <a:t>In your repo, open README.md and click the pencil icon to edit it.</a:t>
             </a:r>
             <a:endParaRPr lang="en-US" sz="1250" dirty="0"/>
           </a:p>
@@ -5483,6 +5647,10 @@
           </a:solidFill>
           <a:ln/>
         </p:spPr>
+        <p:txBody>
+          <a:bodyPr/>
+          <a:p/>
+        </p:txBody>
       </p:sp>
       <p:sp>
         <p:nvSpPr>
@@ -5556,7 +5724,7 @@
                 <a:ea typeface="Open Sans" pitchFamily="34" charset="-122"/>
                 <a:cs typeface="Open Sans" pitchFamily="34" charset="-120"/>
               </a:rPr>
-              <a:t>Name the file BIO.md</a:t>
+              <a:t>Replace its contents with your bio.</a:t>
             </a:r>
             <a:endParaRPr lang="en-US" sz="1250" dirty="0"/>
           </a:p>
@@ -5581,6 +5749,10 @@
           </a:solidFill>
           <a:ln/>
         </p:spPr>
+        <p:txBody>
+          <a:bodyPr/>
+          <a:p/>
+        </p:txBody>
       </p:sp>
       <p:sp>
         <p:nvSpPr>
@@ -5682,6 +5854,10 @@
             <a:prstDash val="solid"/>
           </a:ln>
         </p:spPr>
+        <p:txBody>
+          <a:bodyPr/>
+          <a:p/>
+        </p:txBody>
       </p:sp>
       <p:sp>
         <p:nvSpPr>
@@ -5716,7 +5892,7 @@
                 <a:ea typeface="Open Sans" pitchFamily="34" charset="-122"/>
                 <a:cs typeface="Open Sans" pitchFamily="34" charset="-120"/>
               </a:rPr>
-              <a:t>Step 2  ·  Add BIO.md</a:t>
+              <a:t>Step 2  ·  Add your bio</a:t>
             </a:r>
             <a:endParaRPr lang="en-US" sz="900" dirty="0"/>
           </a:p>
@@ -5812,6 +5988,10 @@
           </a:solidFill>
           <a:ln/>
         </p:spPr>
+        <p:txBody>
+          <a:bodyPr/>
+          <a:p/>
+        </p:txBody>
       </p:sp>
       <p:sp>
         <p:nvSpPr>
@@ -5949,6 +6129,10 @@
           </a:solidFill>
           <a:ln/>
         </p:spPr>
+        <p:txBody>
+          <a:bodyPr/>
+          <a:p/>
+        </p:txBody>
       </p:sp>
       <p:sp>
         <p:nvSpPr>
@@ -6047,6 +6231,10 @@
           </a:solidFill>
           <a:ln/>
         </p:spPr>
+        <p:txBody>
+          <a:bodyPr/>
+          <a:p/>
+        </p:txBody>
       </p:sp>
       <p:sp>
         <p:nvSpPr>
@@ -6145,6 +6333,10 @@
           </a:solidFill>
           <a:ln/>
         </p:spPr>
+        <p:txBody>
+          <a:bodyPr/>
+          <a:p/>
+        </p:txBody>
       </p:sp>
       <p:sp>
         <p:nvSpPr>
@@ -6243,6 +6435,10 @@
           </a:solidFill>
           <a:ln/>
         </p:spPr>
+        <p:txBody>
+          <a:bodyPr/>
+          <a:p/>
+        </p:txBody>
       </p:sp>
       <p:sp>
         <p:nvSpPr>
@@ -6348,6 +6544,10 @@
             </a:outerShdw>
           </a:effectLst>
         </p:spPr>
+        <p:txBody>
+          <a:bodyPr/>
+          <a:p/>
+        </p:txBody>
       </p:sp>
       <p:sp>
         <p:nvSpPr>
@@ -6446,6 +6646,10 @@
           </a:solidFill>
           <a:ln/>
         </p:spPr>
+        <p:txBody>
+          <a:bodyPr/>
+          <a:p/>
+        </p:txBody>
       </p:sp>
       <p:sp>
         <p:nvSpPr>
@@ -6547,6 +6751,10 @@
             <a:prstDash val="solid"/>
           </a:ln>
         </p:spPr>
+        <p:txBody>
+          <a:bodyPr/>
+          <a:p/>
+        </p:txBody>
       </p:sp>
       <p:sp>
         <p:nvSpPr>
@@ -6677,6 +6885,10 @@
           </a:solidFill>
           <a:ln/>
         </p:spPr>
+        <p:txBody>
+          <a:bodyPr/>
+          <a:p/>
+        </p:txBody>
       </p:sp>
       <p:sp>
         <p:nvSpPr>
@@ -6814,6 +7026,10 @@
           </a:solidFill>
           <a:ln/>
         </p:spPr>
+        <p:txBody>
+          <a:bodyPr/>
+          <a:p/>
+        </p:txBody>
       </p:sp>
       <p:sp>
         <p:nvSpPr>
@@ -6887,7 +7103,7 @@
                 <a:ea typeface="Open Sans" pitchFamily="34" charset="-122"/>
                 <a:cs typeface="Open Sans" pitchFamily="34" charset="-120"/>
               </a:rPr>
-              <a:t>Copy your repo URL, e.g. github.com/you/bus313-portfolio</a:t>
+              <a:t>Copy your repo URL, e.g. github.com/you/firstname-lastname</a:t>
             </a:r>
             <a:endParaRPr lang="en-US" sz="1350" dirty="0"/>
           </a:p>
@@ -6912,6 +7128,10 @@
           </a:solidFill>
           <a:ln/>
         </p:spPr>
+        <p:txBody>
+          <a:bodyPr/>
+          <a:p/>
+        </p:txBody>
       </p:sp>
       <p:sp>
         <p:nvSpPr>
@@ -7010,6 +7230,10 @@
           </a:solidFill>
           <a:ln/>
         </p:spPr>
+        <p:txBody>
+          <a:bodyPr/>
+          <a:p/>
+        </p:txBody>
       </p:sp>
       <p:sp>
         <p:nvSpPr>
@@ -7108,6 +7332,10 @@
           </a:solidFill>
           <a:ln/>
         </p:spPr>
+        <p:txBody>
+          <a:bodyPr/>
+          <a:p/>
+        </p:txBody>
       </p:sp>
       <p:sp>
         <p:nvSpPr>
@@ -7521,7 +7749,7 @@
                           <a:ea typeface="Open Sans" pitchFamily="34" charset="-122"/>
                           <a:cs typeface="Open Sans" pitchFamily="34" charset="-120"/>
                         </a:rPr>
-                        <a:t>BIO.md present and complete (150–200 words)</a:t>
+                        <a:t>Bio in README.md, present and complete (150–200 words)</a:t>
                       </a:r>
                       <a:endParaRPr lang="en-US" sz="1250" dirty="0">
                         <a:latin typeface="Open Sans" charset="0"/>
@@ -7982,6 +8210,10 @@
             <a:prstDash val="solid"/>
           </a:ln>
         </p:spPr>
+        <p:txBody>
+          <a:bodyPr/>
+          <a:p/>
+        </p:txBody>
       </p:sp>
       <p:sp>
         <p:nvSpPr>
@@ -8112,6 +8344,10 @@
           </a:solidFill>
           <a:ln/>
         </p:spPr>
+        <p:txBody>
+          <a:bodyPr/>
+          <a:p/>
+        </p:txBody>
       </p:sp>
       <p:sp>
         <p:nvSpPr>
@@ -8215,6 +8451,10 @@
             <a:prstDash val="solid"/>
           </a:ln>
         </p:spPr>
+        <p:txBody>
+          <a:bodyPr/>
+          <a:p/>
+        </p:txBody>
       </p:sp>
       <p:sp>
         <p:nvSpPr>
@@ -8235,6 +8475,10 @@
           </a:solidFill>
           <a:ln/>
         </p:spPr>
+        <p:txBody>
+          <a:bodyPr/>
+          <a:p/>
+        </p:txBody>
       </p:sp>
       <p:sp>
         <p:nvSpPr>
@@ -8377,6 +8621,10 @@
             <a:prstDash val="solid"/>
           </a:ln>
         </p:spPr>
+        <p:txBody>
+          <a:bodyPr/>
+          <a:p/>
+        </p:txBody>
       </p:sp>
       <p:sp>
         <p:nvSpPr>
@@ -8397,6 +8645,10 @@
           </a:solidFill>
           <a:ln/>
         </p:spPr>
+        <p:txBody>
+          <a:bodyPr/>
+          <a:p/>
+        </p:txBody>
       </p:sp>
       <p:sp>
         <p:nvSpPr>
@@ -8470,7 +8722,7 @@
                 <a:ea typeface="Open Sans" pitchFamily="34" charset="-122"/>
                 <a:cs typeface="Open Sans" pitchFamily="34" charset="-120"/>
               </a:rPr>
-              <a:t>Add BIO.md</a:t>
+              <a:t>Add your bio</a:t>
             </a:r>
             <a:endParaRPr lang="en-US" sz="1700" dirty="0"/>
           </a:p>
@@ -8539,6 +8791,10 @@
             <a:prstDash val="solid"/>
           </a:ln>
         </p:spPr>
+        <p:txBody>
+          <a:bodyPr/>
+          <a:p/>
+        </p:txBody>
       </p:sp>
       <p:sp>
         <p:nvSpPr>
@@ -8559,6 +8815,10 @@
           </a:solidFill>
           <a:ln/>
         </p:spPr>
+        <p:txBody>
+          <a:bodyPr/>
+          <a:p/>
+        </p:txBody>
       </p:sp>
       <p:sp>
         <p:nvSpPr>
@@ -8696,6 +8956,10 @@
           </a:solidFill>
           <a:ln/>
         </p:spPr>
+        <p:txBody>
+          <a:bodyPr/>
+          <a:p/>
+        </p:txBody>
       </p:sp>
       <p:sp>
         <p:nvSpPr>

</xml_diff>